<commit_message>
Deck: add prior-work comparison slide (Active Reasoning / ADAM / AXIOM vs ours) — 14 slides
Co-Authored-By: Claude Opus 4.8 <noreply@anthropic.com>
</commit_message>
<xml_diff>
--- a/neurosymbolic/ARC_AGI3_neurosymbolic.pptx
+++ b/neurosymbolic/ARC_AGI3_neurosymbolic.pptx
@@ -18,6 +18,7 @@
     <p:sldId id="266" r:id="rId17"/>
     <p:sldId id="267" r:id="rId18"/>
     <p:sldId id="268" r:id="rId19"/>
+    <p:sldId id="269" r:id="rId20"/>
   </p:sldIdLst>
   <p:sldSz cx="12191695" cy="6858000" type="screen4x3"/>
   <p:notesSz cx="6858000" cy="9144000"/>
@@ -3961,7 +3962,7 @@
           <a:noFill/>
         </p:spPr>
         <p:txBody>
-          <a:bodyPr wrap="square">
+          <a:bodyPr wrap="none">
             <a:spAutoFit/>
           </a:bodyPr>
           <a:lstStyle/>
@@ -3975,21 +3976,904 @@
               </a:defRPr>
             </a:pPr>
             <a:r>
-              <a:t>11 · 整体版图 &amp; 下一步</a:t>
-            </a:r>
-          </a:p>
-        </p:txBody>
-      </p:sp>
-      <p:sp>
-        <p:nvSpPr>
-          <p:cNvPr id="4" name="TextBox 3"/>
+              <a:t>11 · 与前人「交互式推理」工作的对比</a:t>
+            </a:r>
+          </a:p>
+        </p:txBody>
+      </p:sp>
+      <p:graphicFrame>
+        <p:nvGraphicFramePr>
+          <p:cNvPr id="4" name="Table 3"/>
+          <p:cNvGraphicFramePr>
+            <a:graphicFrameLocks noGrp="1"/>
+          </p:cNvGraphicFramePr>
+          <p:nvPr/>
+        </p:nvGraphicFramePr>
+        <p:xfrm>
+          <a:off x="640080" y="1371600"/>
+          <a:ext cx="10881360" cy="3200400"/>
+        </p:xfrm>
+        <a:graphic>
+          <a:graphicData uri="http://schemas.openxmlformats.org/drawingml/2006/table">
+            <a:tbl>
+              <a:tblPr firstRow="1" bandRow="1">
+                <a:tableStyleId>{5C22544A-7EE6-4342-B048-85BDC9FD1C3A}</a:tableStyleId>
+              </a:tblPr>
+              <a:tblGrid>
+                <a:gridCol w="1097280"/>
+                <a:gridCol w="2423160"/>
+                <a:gridCol w="2468880"/>
+                <a:gridCol w="2423160"/>
+                <a:gridCol w="2468880"/>
+              </a:tblGrid>
+              <a:tr h="457200">
+                <a:tc>
+                  <a:txBody>
+                    <a:bodyPr/>
+                    <a:lstStyle/>
+                    <a:p>
+                      <a:pPr>
+                        <a:defRPr sz="1500" b="1">
+                          <a:solidFill>
+                            <a:srgbClr val="FFFFFF"/>
+                          </a:solidFill>
+                          <a:latin typeface="Microsoft YaHei"/>
+                        </a:defRPr>
+                      </a:pPr>
+                      <a:r>
+                        <a:t>维度</a:t>
+                      </a:r>
+                    </a:p>
+                  </a:txBody>
+                  <a:tcPr>
+                    <a:solidFill>
+                      <a:srgbClr val="1F6FB2"/>
+                    </a:solidFill>
+                  </a:tcPr>
+                </a:tc>
+                <a:tc>
+                  <a:txBody>
+                    <a:bodyPr/>
+                    <a:lstStyle/>
+                    <a:p>
+                      <a:pPr>
+                        <a:defRPr sz="1500" b="1">
+                          <a:solidFill>
+                            <a:srgbClr val="FFFFFF"/>
+                          </a:solidFill>
+                          <a:latin typeface="Microsoft YaHei"/>
+                        </a:defRPr>
+                      </a:pPr>
+                      <a:r>
+                        <a:t>Active Reasoning (Conan)</a:t>
+                      </a:r>
+                    </a:p>
+                  </a:txBody>
+                  <a:tcPr>
+                    <a:solidFill>
+                      <a:srgbClr val="1F6FB2"/>
+                    </a:solidFill>
+                  </a:tcPr>
+                </a:tc>
+                <a:tc>
+                  <a:txBody>
+                    <a:bodyPr/>
+                    <a:lstStyle/>
+                    <a:p>
+                      <a:pPr>
+                        <a:defRPr sz="1500" b="1">
+                          <a:solidFill>
+                            <a:srgbClr val="FFFFFF"/>
+                          </a:solidFill>
+                          <a:latin typeface="Microsoft YaHei"/>
+                        </a:defRPr>
+                      </a:pPr>
+                      <a:r>
+                        <a:t>ADAM</a:t>
+                      </a:r>
+                    </a:p>
+                  </a:txBody>
+                  <a:tcPr>
+                    <a:solidFill>
+                      <a:srgbClr val="1F6FB2"/>
+                    </a:solidFill>
+                  </a:tcPr>
+                </a:tc>
+                <a:tc>
+                  <a:txBody>
+                    <a:bodyPr/>
+                    <a:lstStyle/>
+                    <a:p>
+                      <a:pPr>
+                        <a:defRPr sz="1500" b="1">
+                          <a:solidFill>
+                            <a:srgbClr val="FFFFFF"/>
+                          </a:solidFill>
+                          <a:latin typeface="Microsoft YaHei"/>
+                        </a:defRPr>
+                      </a:pPr>
+                      <a:r>
+                        <a:t>AXIOM</a:t>
+                      </a:r>
+                    </a:p>
+                  </a:txBody>
+                  <a:tcPr>
+                    <a:solidFill>
+                      <a:srgbClr val="1F6FB2"/>
+                    </a:solidFill>
+                  </a:tcPr>
+                </a:tc>
+                <a:tc>
+                  <a:txBody>
+                    <a:bodyPr/>
+                    <a:lstStyle/>
+                    <a:p>
+                      <a:pPr>
+                        <a:defRPr sz="1500" b="1">
+                          <a:solidFill>
+                            <a:srgbClr val="FFFFFF"/>
+                          </a:solidFill>
+                          <a:latin typeface="Microsoft YaHei"/>
+                        </a:defRPr>
+                      </a:pPr>
+                      <a:r>
+                        <a:t>我们(源码无关)</a:t>
+                      </a:r>
+                    </a:p>
+                  </a:txBody>
+                  <a:tcPr>
+                    <a:solidFill>
+                      <a:srgbClr val="1F6FB2"/>
+                    </a:solidFill>
+                  </a:tcPr>
+                </a:tc>
+              </a:tr>
+              <a:tr h="457200">
+                <a:tc>
+                  <a:txBody>
+                    <a:bodyPr/>
+                    <a:lstStyle/>
+                    <a:p>
+                      <a:pPr>
+                        <a:defRPr sz="1300" b="1">
+                          <a:solidFill>
+                            <a:srgbClr val="444A55"/>
+                          </a:solidFill>
+                          <a:latin typeface="Microsoft YaHei"/>
+                        </a:defRPr>
+                      </a:pPr>
+                      <a:r>
+                        <a:t>感知</a:t>
+                      </a:r>
+                    </a:p>
+                  </a:txBody>
+                  <a:tcPr>
+                    <a:solidFill>
+                      <a:srgbClr val="FFFFFF"/>
+                    </a:solidFill>
+                  </a:tcPr>
+                </a:tc>
+                <a:tc>
+                  <a:txBody>
+                    <a:bodyPr/>
+                    <a:lstStyle/>
+                    <a:p>
+                      <a:pPr>
+                        <a:defRPr sz="1300" b="0">
+                          <a:solidFill>
+                            <a:srgbClr val="444A55"/>
+                          </a:solidFill>
+                          <a:latin typeface="Microsoft YaHei"/>
+                        </a:defRPr>
+                      </a:pPr>
+                      <a:r>
+                        <a:t>符号/结构(非像素)</a:t>
+                      </a:r>
+                    </a:p>
+                  </a:txBody>
+                  <a:tcPr>
+                    <a:solidFill>
+                      <a:srgbClr val="FFFFFF"/>
+                    </a:solidFill>
+                  </a:tcPr>
+                </a:tc>
+                <a:tc>
+                  <a:txBody>
+                    <a:bodyPr/>
+                    <a:lstStyle/>
+                    <a:p>
+                      <a:pPr>
+                        <a:defRPr sz="1300" b="0">
+                          <a:solidFill>
+                            <a:srgbClr val="444A55"/>
+                          </a:solidFill>
+                          <a:latin typeface="Microsoft YaHei"/>
+                        </a:defRPr>
+                      </a:pPr>
+                      <a:r>
+                        <a:t>截图→MLLM 文本+背包</a:t>
+                      </a:r>
+                    </a:p>
+                  </a:txBody>
+                  <a:tcPr>
+                    <a:solidFill>
+                      <a:srgbClr val="FFFFFF"/>
+                    </a:solidFill>
+                  </a:tcPr>
+                </a:tc>
+                <a:tc>
+                  <a:txBody>
+                    <a:bodyPr/>
+                    <a:lstStyle/>
+                    <a:p>
+                      <a:pPr>
+                        <a:defRPr sz="1300" b="0">
+                          <a:solidFill>
+                            <a:srgbClr val="444A55"/>
+                          </a:solidFill>
+                          <a:latin typeface="Microsoft YaHei"/>
+                        </a:defRPr>
+                      </a:pPr>
+                      <a:r>
+                        <a:t>原始像素→物体槽(sMM)</a:t>
+                      </a:r>
+                    </a:p>
+                  </a:txBody>
+                  <a:tcPr>
+                    <a:solidFill>
+                      <a:srgbClr val="FFFFFF"/>
+                    </a:solidFill>
+                  </a:tcPr>
+                </a:tc>
+                <a:tc>
+                  <a:txBody>
+                    <a:bodyPr/>
+                    <a:lstStyle/>
+                    <a:p>
+                      <a:pPr>
+                        <a:defRPr sz="1300" b="0">
+                          <a:solidFill>
+                            <a:srgbClr val="444A55"/>
+                          </a:solidFill>
+                          <a:latin typeface="Microsoft YaHei"/>
+                        </a:defRPr>
+                      </a:pPr>
+                      <a:r>
+                        <a:t>原始像素,仅胜负反馈</a:t>
+                      </a:r>
+                    </a:p>
+                  </a:txBody>
+                  <a:tcPr>
+                    <a:solidFill>
+                      <a:srgbClr val="FFFFFF"/>
+                    </a:solidFill>
+                  </a:tcPr>
+                </a:tc>
+              </a:tr>
+              <a:tr h="457200">
+                <a:tc>
+                  <a:txBody>
+                    <a:bodyPr/>
+                    <a:lstStyle/>
+                    <a:p>
+                      <a:pPr>
+                        <a:defRPr sz="1300" b="1">
+                          <a:solidFill>
+                            <a:srgbClr val="444A55"/>
+                          </a:solidFill>
+                          <a:latin typeface="Microsoft YaHei"/>
+                        </a:defRPr>
+                      </a:pPr>
+                      <a:r>
+                        <a:t>探索推理</a:t>
+                      </a:r>
+                    </a:p>
+                  </a:txBody>
+                  <a:tcPr>
+                    <a:solidFill>
+                      <a:srgbClr val="F2F5FA"/>
+                    </a:solidFill>
+                  </a:tcPr>
+                </a:tc>
+                <a:tc>
+                  <a:txBody>
+                    <a:bodyPr/>
+                    <a:lstStyle/>
+                    <a:p>
+                      <a:pPr>
+                        <a:defRPr sz="1300" b="0">
+                          <a:solidFill>
+                            <a:srgbClr val="444A55"/>
+                          </a:solidFill>
+                          <a:latin typeface="Microsoft YaHei"/>
+                        </a:defRPr>
+                      </a:pPr>
+                      <a:r>
+                        <a:t>主动溯因,多轮取证</a:t>
+                      </a:r>
+                    </a:p>
+                  </a:txBody>
+                  <a:tcPr>
+                    <a:solidFill>
+                      <a:srgbClr val="F2F5FA"/>
+                    </a:solidFill>
+                  </a:tcPr>
+                </a:tc>
+                <a:tc>
+                  <a:txBody>
+                    <a:bodyPr/>
+                    <a:lstStyle/>
+                    <a:p>
+                      <a:pPr>
+                        <a:defRPr sz="1300" b="0">
+                          <a:solidFill>
+                            <a:srgbClr val="444A55"/>
+                          </a:solidFill>
+                          <a:latin typeface="Microsoft YaHei"/>
+                        </a:defRPr>
+                      </a:pPr>
+                      <a:r>
+                        <a:t>采样动作→LLM 因果发现→干预验证</a:t>
+                      </a:r>
+                    </a:p>
+                  </a:txBody>
+                  <a:tcPr>
+                    <a:solidFill>
+                      <a:srgbClr val="F2F5FA"/>
+                    </a:solidFill>
+                  </a:tcPr>
+                </a:tc>
+                <a:tc>
+                  <a:txBody>
+                    <a:bodyPr/>
+                    <a:lstStyle/>
+                    <a:p>
+                      <a:pPr>
+                        <a:defRPr sz="1300" b="0">
+                          <a:solidFill>
+                            <a:srgbClr val="444A55"/>
+                          </a:solidFill>
+                          <a:latin typeface="Microsoft YaHei"/>
+                        </a:defRPr>
+                      </a:pPr>
+                      <a:r>
+                        <a:t>主动推理(期望自由能)</a:t>
+                      </a:r>
+                    </a:p>
+                  </a:txBody>
+                  <a:tcPr>
+                    <a:solidFill>
+                      <a:srgbClr val="F2F5FA"/>
+                    </a:solidFill>
+                  </a:tcPr>
+                </a:tc>
+                <a:tc>
+                  <a:txBody>
+                    <a:bodyPr/>
+                    <a:lstStyle/>
+                    <a:p>
+                      <a:pPr>
+                        <a:defRPr sz="1300" b="0">
+                          <a:solidFill>
+                            <a:srgbClr val="444A55"/>
+                          </a:solidFill>
+                          <a:latin typeface="Microsoft YaHei"/>
+                        </a:defRPr>
+                      </a:pPr>
+                      <a:r>
+                        <a:t>探测→建图→交互发现角色→反推隐藏能量→规划</a:t>
+                      </a:r>
+                    </a:p>
+                  </a:txBody>
+                  <a:tcPr>
+                    <a:solidFill>
+                      <a:srgbClr val="F2F5FA"/>
+                    </a:solidFill>
+                  </a:tcPr>
+                </a:tc>
+              </a:tr>
+              <a:tr h="457200">
+                <a:tc>
+                  <a:txBody>
+                    <a:bodyPr/>
+                    <a:lstStyle/>
+                    <a:p>
+                      <a:pPr>
+                        <a:defRPr sz="1300" b="1">
+                          <a:solidFill>
+                            <a:srgbClr val="444A55"/>
+                          </a:solidFill>
+                          <a:latin typeface="Microsoft YaHei"/>
+                        </a:defRPr>
+                      </a:pPr>
+                      <a:r>
+                        <a:t>模型</a:t>
+                      </a:r>
+                    </a:p>
+                  </a:txBody>
+                  <a:tcPr>
+                    <a:solidFill>
+                      <a:srgbClr val="FFFFFF"/>
+                    </a:solidFill>
+                  </a:tcPr>
+                </a:tc>
+                <a:tc>
+                  <a:txBody>
+                    <a:bodyPr/>
+                    <a:lstStyle/>
+                    <a:p>
+                      <a:pPr>
+                        <a:defRPr sz="1300" b="0">
+                          <a:solidFill>
+                            <a:srgbClr val="444A55"/>
+                          </a:solidFill>
+                          <a:latin typeface="Microsoft YaHei"/>
+                        </a:defRPr>
+                      </a:pPr>
+                      <a:r>
+                        <a:t>Bayes 重构溯因</a:t>
+                      </a:r>
+                    </a:p>
+                  </a:txBody>
+                  <a:tcPr>
+                    <a:solidFill>
+                      <a:srgbClr val="FFFFFF"/>
+                    </a:solidFill>
+                  </a:tcPr>
+                </a:tc>
+                <a:tc>
+                  <a:txBody>
+                    <a:bodyPr/>
+                    <a:lstStyle/>
+                    <a:p>
+                      <a:pPr>
+                        <a:defRPr sz="1300" b="0">
+                          <a:solidFill>
+                            <a:srgbClr val="444A55"/>
+                          </a:solidFill>
+                          <a:latin typeface="Microsoft YaHei"/>
+                        </a:defRPr>
+                      </a:pPr>
+                      <a:r>
+                        <a:t>GPT-4-turbo + LLaVA-13B(大闭源)</a:t>
+                      </a:r>
+                    </a:p>
+                  </a:txBody>
+                  <a:tcPr>
+                    <a:solidFill>
+                      <a:srgbClr val="FFFFFF"/>
+                    </a:solidFill>
+                  </a:tcPr>
+                </a:tc>
+                <a:tc>
+                  <a:txBody>
+                    <a:bodyPr/>
+                    <a:lstStyle/>
+                    <a:p>
+                      <a:pPr>
+                        <a:defRPr sz="1300" b="0">
+                          <a:solidFill>
+                            <a:srgbClr val="444A55"/>
+                          </a:solidFill>
+                          <a:latin typeface="Microsoft YaHei"/>
+                        </a:defRPr>
+                      </a:pPr>
+                      <a:r>
+                        <a:t>贝叶斯/无梯度,0.3–1.6M 参数</a:t>
+                      </a:r>
+                    </a:p>
+                  </a:txBody>
+                  <a:tcPr>
+                    <a:solidFill>
+                      <a:srgbClr val="FFFFFF"/>
+                    </a:solidFill>
+                  </a:tcPr>
+                </a:tc>
+                <a:tc>
+                  <a:txBody>
+                    <a:bodyPr/>
+                    <a:lstStyle/>
+                    <a:p>
+                      <a:pPr>
+                        <a:defRPr sz="1300" b="0">
+                          <a:solidFill>
+                            <a:srgbClr val="444A55"/>
+                          </a:solidFill>
+                          <a:latin typeface="Microsoft YaHei"/>
+                        </a:defRPr>
+                      </a:pPr>
+                      <a:r>
+                        <a:t>免费本地模型可选;主体免模型符号规划</a:t>
+                      </a:r>
+                    </a:p>
+                  </a:txBody>
+                  <a:tcPr>
+                    <a:solidFill>
+                      <a:srgbClr val="FFFFFF"/>
+                    </a:solidFill>
+                  </a:tcPr>
+                </a:tc>
+              </a:tr>
+              <a:tr h="457200">
+                <a:tc>
+                  <a:txBody>
+                    <a:bodyPr/>
+                    <a:lstStyle/>
+                    <a:p>
+                      <a:pPr>
+                        <a:defRPr sz="1300" b="1">
+                          <a:solidFill>
+                            <a:srgbClr val="444A55"/>
+                          </a:solidFill>
+                          <a:latin typeface="Microsoft YaHei"/>
+                        </a:defRPr>
+                      </a:pPr>
+                      <a:r>
+                        <a:t>训练/控制</a:t>
+                      </a:r>
+                    </a:p>
+                  </a:txBody>
+                  <a:tcPr>
+                    <a:solidFill>
+                      <a:srgbClr val="F2F5FA"/>
+                    </a:solidFill>
+                  </a:tcPr>
+                </a:tc>
+                <a:tc>
+                  <a:txBody>
+                    <a:bodyPr/>
+                    <a:lstStyle/>
+                    <a:p>
+                      <a:pPr>
+                        <a:defRPr sz="1300" b="0">
+                          <a:solidFill>
+                            <a:srgbClr val="444A55"/>
+                          </a:solidFill>
+                          <a:latin typeface="Microsoft YaHei"/>
+                        </a:defRPr>
+                      </a:pPr>
+                      <a:r>
+                        <a:t>—</a:t>
+                      </a:r>
+                    </a:p>
+                  </a:txBody>
+                  <a:tcPr>
+                    <a:solidFill>
+                      <a:srgbClr val="F2F5FA"/>
+                    </a:solidFill>
+                  </a:tcPr>
+                </a:tc>
+                <a:tc>
+                  <a:txBody>
+                    <a:bodyPr/>
+                    <a:lstStyle/>
+                    <a:p>
+                      <a:pPr>
+                        <a:defRPr sz="1300" b="0">
+                          <a:solidFill>
+                            <a:srgbClr val="444A55"/>
+                          </a:solidFill>
+                          <a:latin typeface="Microsoft YaHei"/>
+                        </a:defRPr>
+                      </a:pPr>
+                      <a:r>
+                        <a:t>免微调,LLM 驱动行动</a:t>
+                      </a:r>
+                    </a:p>
+                  </a:txBody>
+                  <a:tcPr>
+                    <a:solidFill>
+                      <a:srgbClr val="F2F5FA"/>
+                    </a:solidFill>
+                  </a:tcPr>
+                </a:tc>
+                <a:tc>
+                  <a:txBody>
+                    <a:bodyPr/>
+                    <a:lstStyle/>
+                    <a:p>
+                      <a:pPr>
+                        <a:defRPr sz="1300" b="0">
+                          <a:solidFill>
+                            <a:srgbClr val="444A55"/>
+                          </a:solidFill>
+                          <a:latin typeface="Microsoft YaHei"/>
+                        </a:defRPr>
+                      </a:pPr>
+                      <a:r>
+                        <a:t>在线贝叶斯,主动推理规划</a:t>
+                      </a:r>
+                    </a:p>
+                  </a:txBody>
+                  <a:tcPr>
+                    <a:solidFill>
+                      <a:srgbClr val="F2F5FA"/>
+                    </a:solidFill>
+                  </a:tcPr>
+                </a:tc>
+                <a:tc>
+                  <a:txBody>
+                    <a:bodyPr/>
+                    <a:lstStyle/>
+                    <a:p>
+                      <a:pPr>
+                        <a:defRPr sz="1300" b="0">
+                          <a:solidFill>
+                            <a:srgbClr val="444A55"/>
+                          </a:solidFill>
+                          <a:latin typeface="Microsoft YaHei"/>
+                        </a:defRPr>
+                      </a:pPr>
+                      <a:r>
+                        <a:t>免训练,经典规划器 + 胜负验证</a:t>
+                      </a:r>
+                    </a:p>
+                  </a:txBody>
+                  <a:tcPr>
+                    <a:solidFill>
+                      <a:srgbClr val="F2F5FA"/>
+                    </a:solidFill>
+                  </a:tcPr>
+                </a:tc>
+              </a:tr>
+              <a:tr h="457200">
+                <a:tc>
+                  <a:txBody>
+                    <a:bodyPr/>
+                    <a:lstStyle/>
+                    <a:p>
+                      <a:pPr>
+                        <a:defRPr sz="1300" b="1">
+                          <a:solidFill>
+                            <a:srgbClr val="444A55"/>
+                          </a:solidFill>
+                          <a:latin typeface="Microsoft YaHei"/>
+                        </a:defRPr>
+                      </a:pPr>
+                      <a:r>
+                        <a:t>隐藏状态</a:t>
+                      </a:r>
+                    </a:p>
+                  </a:txBody>
+                  <a:tcPr>
+                    <a:solidFill>
+                      <a:srgbClr val="FFFFFF"/>
+                    </a:solidFill>
+                  </a:tcPr>
+                </a:tc>
+                <a:tc>
+                  <a:txBody>
+                    <a:bodyPr/>
+                    <a:lstStyle/>
+                    <a:p>
+                      <a:pPr>
+                        <a:defRPr sz="1300" b="0">
+                          <a:solidFill>
+                            <a:srgbClr val="444A55"/>
+                          </a:solidFill>
+                          <a:latin typeface="Microsoft YaHei"/>
+                        </a:defRPr>
+                      </a:pPr>
+                      <a:r>
+                        <a:t>信息不全→溯因</a:t>
+                      </a:r>
+                    </a:p>
+                  </a:txBody>
+                  <a:tcPr>
+                    <a:solidFill>
+                      <a:srgbClr val="FFFFFF"/>
+                    </a:solidFill>
+                  </a:tcPr>
+                </a:tc>
+                <a:tc>
+                  <a:txBody>
+                    <a:bodyPr/>
+                    <a:lstStyle/>
+                    <a:p>
+                      <a:pPr>
+                        <a:defRPr sz="1300" b="0">
+                          <a:solidFill>
+                            <a:srgbClr val="444A55"/>
+                          </a:solidFill>
+                          <a:latin typeface="Microsoft YaHei"/>
+                        </a:defRPr>
+                      </a:pPr>
+                      <a:r>
+                        <a:t>因果图</a:t>
+                      </a:r>
+                    </a:p>
+                  </a:txBody>
+                  <a:tcPr>
+                    <a:solidFill>
+                      <a:srgbClr val="FFFFFF"/>
+                    </a:solidFill>
+                  </a:tcPr>
+                </a:tc>
+                <a:tc>
+                  <a:txBody>
+                    <a:bodyPr/>
+                    <a:lstStyle/>
+                    <a:p>
+                      <a:pPr>
+                        <a:defRPr sz="1300" b="0">
+                          <a:solidFill>
+                            <a:srgbClr val="444A55"/>
+                          </a:solidFill>
+                          <a:latin typeface="Microsoft YaHei"/>
+                        </a:defRPr>
+                      </a:pPr>
+                      <a:r>
+                        <a:t>隐变量混合参数</a:t>
+                      </a:r>
+                    </a:p>
+                  </a:txBody>
+                  <a:tcPr>
+                    <a:solidFill>
+                      <a:srgbClr val="FFFFFF"/>
+                    </a:solidFill>
+                  </a:tcPr>
+                </a:tc>
+                <a:tc>
+                  <a:txBody>
+                    <a:bodyPr/>
+                    <a:lstStyle/>
+                    <a:p>
+                      <a:pPr>
+                        <a:defRPr sz="1300" b="0">
+                          <a:solidFill>
+                            <a:srgbClr val="444A55"/>
+                          </a:solidFill>
+                          <a:latin typeface="Microsoft YaHei"/>
+                        </a:defRPr>
+                      </a:pPr>
+                      <a:r>
+                        <a:t>显式不可见变量(能量)靠「走到死」反推</a:t>
+                      </a:r>
+                    </a:p>
+                  </a:txBody>
+                  <a:tcPr>
+                    <a:solidFill>
+                      <a:srgbClr val="FFFFFF"/>
+                    </a:solidFill>
+                  </a:tcPr>
+                </a:tc>
+              </a:tr>
+              <a:tr h="457200">
+                <a:tc>
+                  <a:txBody>
+                    <a:bodyPr/>
+                    <a:lstStyle/>
+                    <a:p>
+                      <a:pPr>
+                        <a:defRPr sz="1300" b="1">
+                          <a:solidFill>
+                            <a:srgbClr val="444A55"/>
+                          </a:solidFill>
+                          <a:latin typeface="Microsoft YaHei"/>
+                        </a:defRPr>
+                      </a:pPr>
+                      <a:r>
+                        <a:t>模态/结果</a:t>
+                      </a:r>
+                    </a:p>
+                  </a:txBody>
+                  <a:tcPr>
+                    <a:solidFill>
+                      <a:srgbClr val="F2F5FA"/>
+                    </a:solidFill>
+                  </a:tcPr>
+                </a:tc>
+                <a:tc>
+                  <a:txBody>
+                    <a:bodyPr/>
+                    <a:lstStyle/>
+                    <a:p>
+                      <a:pPr>
+                        <a:defRPr sz="1300" b="0">
+                          <a:solidFill>
+                            <a:srgbClr val="444A55"/>
+                          </a:solidFill>
+                          <a:latin typeface="Microsoft YaHei"/>
+                        </a:defRPr>
+                      </a:pPr>
+                      <a:r>
+                        <a:t>证明 SOTA 在主动推理上失败</a:t>
+                      </a:r>
+                    </a:p>
+                  </a:txBody>
+                  <a:tcPr>
+                    <a:solidFill>
+                      <a:srgbClr val="F2F5FA"/>
+                    </a:solidFill>
+                  </a:tcPr>
+                </a:tc>
+                <a:tc>
+                  <a:txBody>
+                    <a:bodyPr/>
+                    <a:lstStyle/>
+                    <a:p>
+                      <a:pPr>
+                        <a:defRPr sz="1300" b="0">
+                          <a:solidFill>
+                            <a:srgbClr val="444A55"/>
+                          </a:solidFill>
+                          <a:latin typeface="Microsoft YaHei"/>
+                        </a:defRPr>
+                      </a:pPr>
+                      <a:r>
+                        <a:t>钻石 2.2× 加速,因果图近完美</a:t>
+                      </a:r>
+                    </a:p>
+                  </a:txBody>
+                  <a:tcPr>
+                    <a:solidFill>
+                      <a:srgbClr val="F2F5FA"/>
+                    </a:solidFill>
+                  </a:tcPr>
+                </a:tc>
+                <a:tc>
+                  <a:txBody>
+                    <a:bodyPr/>
+                    <a:lstStyle/>
+                    <a:p>
+                      <a:pPr>
+                        <a:defRPr sz="1300" b="0">
+                          <a:solidFill>
+                            <a:srgbClr val="444A55"/>
+                          </a:solidFill>
+                          <a:latin typeface="Microsoft YaHei"/>
+                        </a:defRPr>
+                      </a:pPr>
+                      <a:r>
+                        <a:t>胜 DreamerV3,~5k 步,极小参数</a:t>
+                      </a:r>
+                    </a:p>
+                  </a:txBody>
+                  <a:tcPr>
+                    <a:solidFill>
+                      <a:srgbClr val="F2F5FA"/>
+                    </a:solidFill>
+                  </a:tcPr>
+                </a:tc>
+                <a:tc>
+                  <a:txBody>
+                    <a:bodyPr/>
+                    <a:lstStyle/>
+                    <a:p>
+                      <a:pPr>
+                        <a:defRPr sz="1300" b="0">
+                          <a:solidFill>
+                            <a:srgbClr val="1B7A43"/>
+                          </a:solidFill>
+                          <a:latin typeface="Microsoft YaHei"/>
+                        </a:defRPr>
+                      </a:pPr>
+                      <a:r>
+                        <a:t>移动+点击双模态;ls20 7/7 + 两点击游戏 L0</a:t>
+                      </a:r>
+                    </a:p>
+                  </a:txBody>
+                  <a:tcPr>
+                    <a:solidFill>
+                      <a:srgbClr val="F2F5FA"/>
+                    </a:solidFill>
+                  </a:tcPr>
+                </a:tc>
+              </a:tr>
+            </a:tbl>
+          </a:graphicData>
+        </a:graphic>
+      </p:graphicFrame>
+      <p:sp>
+        <p:nvSpPr>
+          <p:cNvPr id="5" name="TextBox 4"/>
           <p:cNvSpPr txBox="1"/>
           <p:nvPr/>
         </p:nvSpPr>
         <p:spPr>
           <a:xfrm>
-            <a:off x="640080" y="1234440"/>
-            <a:ext cx="10972800" cy="5120640"/>
+            <a:off x="640080" y="6355080"/>
+            <a:ext cx="10972800" cy="365760"/>
           </a:xfrm>
           <a:prstGeom prst="rect">
             <a:avLst/>
@@ -3997,120 +4881,21 @@
           <a:noFill/>
         </p:spPr>
         <p:txBody>
-          <a:bodyPr wrap="square">
+          <a:bodyPr wrap="none">
             <a:spAutoFit/>
           </a:bodyPr>
           <a:lstStyle/>
           <a:p>
             <a:pPr>
-              <a:spcAft>
-                <a:spcPts val="700"/>
-              </a:spcAft>
-              <a:defRPr sz="1800" b="1">
-                <a:solidFill>
-                  <a:srgbClr val="122A4A"/>
-                </a:solidFill>
-                <a:latin typeface="Microsoft YaHei"/>
-              </a:defRPr>
-            </a:pPr>
-            <a:r>
-              <a:t>• ① 符号规划 7/7（证明 ls20 可解）</a:t>
-            </a:r>
-          </a:p>
-          <a:p>
-            <a:pPr>
-              <a:spcAft>
-                <a:spcPts val="700"/>
-              </a:spcAft>
-              <a:defRPr sz="1800" b="1">
-                <a:solidFill>
-                  <a:srgbClr val="122A4A"/>
-                </a:solidFill>
-                <a:latin typeface="Microsoft YaHei"/>
-              </a:defRPr>
-            </a:pPr>
-            <a:r>
-              <a:t>• ② 免费 LLM 归纳 3/7（证明 LLM 能写动力学代码）</a:t>
-            </a:r>
-          </a:p>
-          <a:p>
-            <a:pPr>
-              <a:spcAft>
-                <a:spcPts val="700"/>
-              </a:spcAft>
-              <a:defRPr sz="1800" b="1">
-                <a:solidFill>
-                  <a:srgbClr val="122A4A"/>
-                </a:solidFill>
-                <a:latin typeface="Microsoft YaHei"/>
-              </a:defRPr>
-            </a:pPr>
-            <a:r>
-              <a:t>• ③ 纯像素源码无关 agent 7/7（证明只凭画面+反馈能自发现全部隐藏规则）</a:t>
-            </a:r>
-          </a:p>
-          <a:p>
-            <a:pPr>
-              <a:spcAft>
-                <a:spcPts val="700"/>
-              </a:spcAft>
-              <a:defRPr sz="1800" b="1">
-                <a:solidFill>
-                  <a:srgbClr val="122A4A"/>
-                </a:solidFill>
-                <a:latin typeface="Microsoft YaHei"/>
-              </a:defRPr>
-            </a:pPr>
-            <a:r>
-              <a:t>• ④ game-agnostic 骨架 + 双模态（3 游戏 L0 全解）+ LLM 适配器接通</a:t>
-            </a:r>
-          </a:p>
-          <a:p>
-            <a:pPr>
-              <a:spcAft>
-                <a:spcPts val="700"/>
-              </a:spcAft>
-              <a:defRPr sz="1800" b="1">
-                <a:solidFill>
-                  <a:srgbClr val="122A4A"/>
-                </a:solidFill>
-                <a:latin typeface="Microsoft YaHei"/>
-              </a:defRPr>
-            </a:pPr>
-            <a:r>
-              <a:t>• 下一步：</a:t>
-            </a:r>
-          </a:p>
-          <a:p>
-            <a:pPr lvl="1">
-              <a:spcAft>
-                <a:spcPts val="700"/>
-              </a:spcAft>
-              <a:defRPr sz="1600" b="0">
-                <a:solidFill>
-                  <a:srgbClr val="444A55"/>
-                </a:solidFill>
-                <a:latin typeface="Microsoft YaHei"/>
-              </a:defRPr>
-            </a:pPr>
-            <a:r>
-              <a:t>– 更聪明的搜索/结构去攻深层关卡（vc33/ft09 L1+）</a:t>
-            </a:r>
-          </a:p>
-          <a:p>
-            <a:pPr lvl="1">
-              <a:spcAft>
-                <a:spcPts val="700"/>
-              </a:spcAft>
-              <a:defRPr sz="1600" b="0">
-                <a:solidFill>
-                  <a:srgbClr val="444A55"/>
-                </a:solidFill>
-                <a:latin typeface="Microsoft YaHei"/>
-              </a:defRPr>
-            </a:pPr>
-            <a:r>
-              <a:t>– LLM 适配器在更多 ARC-AGI-3 公开游戏上量跨游戏迁移率（对标 Symbolica 36%）</a:t>
+              <a:defRPr sz="1200" b="1">
+                <a:solidFill>
+                  <a:srgbClr val="1F6FB2"/>
+                </a:solidFill>
+                <a:latin typeface="Microsoft YaHei"/>
+              </a:defRPr>
+            </a:pPr>
+            <a:r>
+              <a:t>最近邻:AXIOM(像素+探索,但贝叶斯/学习)· ADAM(干预发现规则,但大闭源+文本)· Active Reasoning(定义问题,证明 SOTA 失败)</a:t>
             </a:r>
           </a:p>
         </p:txBody>
@@ -4207,7 +4992,239 @@
               </a:defRPr>
             </a:pPr>
             <a:r>
-              <a:t>12 · 结论</a:t>
+              <a:t>12 · 整体版图 &amp; 下一步</a:t>
+            </a:r>
+          </a:p>
+        </p:txBody>
+      </p:sp>
+      <p:sp>
+        <p:nvSpPr>
+          <p:cNvPr id="4" name="TextBox 3"/>
+          <p:cNvSpPr txBox="1"/>
+          <p:nvPr/>
+        </p:nvSpPr>
+        <p:spPr>
+          <a:xfrm>
+            <a:off x="640080" y="1234440"/>
+            <a:ext cx="10972800" cy="5120640"/>
+          </a:xfrm>
+          <a:prstGeom prst="rect">
+            <a:avLst/>
+          </a:prstGeom>
+          <a:noFill/>
+        </p:spPr>
+        <p:txBody>
+          <a:bodyPr wrap="square">
+            <a:spAutoFit/>
+          </a:bodyPr>
+          <a:lstStyle/>
+          <a:p>
+            <a:pPr>
+              <a:spcAft>
+                <a:spcPts val="700"/>
+              </a:spcAft>
+              <a:defRPr sz="1800" b="1">
+                <a:solidFill>
+                  <a:srgbClr val="122A4A"/>
+                </a:solidFill>
+                <a:latin typeface="Microsoft YaHei"/>
+              </a:defRPr>
+            </a:pPr>
+            <a:r>
+              <a:t>• ① 符号规划 7/7（证明 ls20 可解）</a:t>
+            </a:r>
+          </a:p>
+          <a:p>
+            <a:pPr>
+              <a:spcAft>
+                <a:spcPts val="700"/>
+              </a:spcAft>
+              <a:defRPr sz="1800" b="1">
+                <a:solidFill>
+                  <a:srgbClr val="122A4A"/>
+                </a:solidFill>
+                <a:latin typeface="Microsoft YaHei"/>
+              </a:defRPr>
+            </a:pPr>
+            <a:r>
+              <a:t>• ② 免费 LLM 归纳 3/7（证明 LLM 能写动力学代码）</a:t>
+            </a:r>
+          </a:p>
+          <a:p>
+            <a:pPr>
+              <a:spcAft>
+                <a:spcPts val="700"/>
+              </a:spcAft>
+              <a:defRPr sz="1800" b="1">
+                <a:solidFill>
+                  <a:srgbClr val="122A4A"/>
+                </a:solidFill>
+                <a:latin typeface="Microsoft YaHei"/>
+              </a:defRPr>
+            </a:pPr>
+            <a:r>
+              <a:t>• ③ 纯像素源码无关 agent 7/7（证明只凭画面+反馈能自发现全部隐藏规则）</a:t>
+            </a:r>
+          </a:p>
+          <a:p>
+            <a:pPr>
+              <a:spcAft>
+                <a:spcPts val="700"/>
+              </a:spcAft>
+              <a:defRPr sz="1800" b="1">
+                <a:solidFill>
+                  <a:srgbClr val="122A4A"/>
+                </a:solidFill>
+                <a:latin typeface="Microsoft YaHei"/>
+              </a:defRPr>
+            </a:pPr>
+            <a:r>
+              <a:t>• ④ game-agnostic 骨架 + 双模态（3 游戏 L0 全解）+ LLM 适配器接通</a:t>
+            </a:r>
+          </a:p>
+          <a:p>
+            <a:pPr>
+              <a:spcAft>
+                <a:spcPts val="700"/>
+              </a:spcAft>
+              <a:defRPr sz="1800" b="1">
+                <a:solidFill>
+                  <a:srgbClr val="122A4A"/>
+                </a:solidFill>
+                <a:latin typeface="Microsoft YaHei"/>
+              </a:defRPr>
+            </a:pPr>
+            <a:r>
+              <a:t>• 下一步：</a:t>
+            </a:r>
+          </a:p>
+          <a:p>
+            <a:pPr lvl="1">
+              <a:spcAft>
+                <a:spcPts val="700"/>
+              </a:spcAft>
+              <a:defRPr sz="1600" b="0">
+                <a:solidFill>
+                  <a:srgbClr val="444A55"/>
+                </a:solidFill>
+                <a:latin typeface="Microsoft YaHei"/>
+              </a:defRPr>
+            </a:pPr>
+            <a:r>
+              <a:t>– 更聪明的搜索/结构去攻深层关卡（vc33/ft09 L1+）</a:t>
+            </a:r>
+          </a:p>
+          <a:p>
+            <a:pPr lvl="1">
+              <a:spcAft>
+                <a:spcPts val="700"/>
+              </a:spcAft>
+              <a:defRPr sz="1600" b="0">
+                <a:solidFill>
+                  <a:srgbClr val="444A55"/>
+                </a:solidFill>
+                <a:latin typeface="Microsoft YaHei"/>
+              </a:defRPr>
+            </a:pPr>
+            <a:r>
+              <a:t>– LLM 适配器在更多 ARC-AGI-3 公开游戏上量跨游戏迁移率（对标 Symbolica 36%）</a:t>
+            </a:r>
+          </a:p>
+        </p:txBody>
+      </p:sp>
+    </p:spTree>
+  </p:cSld>
+  <p:clrMapOvr>
+    <a:masterClrMapping/>
+  </p:clrMapOvr>
+</p:sld>
+</file>
+
+<file path=ppt/slides/slide14.xml><?xml version="1.0" encoding="utf-8"?>
+<p:sld xmlns:a="http://schemas.openxmlformats.org/drawingml/2006/main" xmlns:p="http://schemas.openxmlformats.org/presentationml/2006/main" xmlns:r="http://schemas.openxmlformats.org/officeDocument/2006/relationships">
+  <p:cSld>
+    <p:spTree>
+      <p:nvGrpSpPr>
+        <p:cNvPr id="1" name=""/>
+        <p:cNvGrpSpPr/>
+        <p:nvPr/>
+      </p:nvGrpSpPr>
+      <p:grpSpPr/>
+      <p:sp>
+        <p:nvSpPr>
+          <p:cNvPr id="2" name="Rectangle 1"/>
+          <p:cNvSpPr/>
+          <p:nvPr/>
+        </p:nvSpPr>
+        <p:spPr>
+          <a:xfrm>
+            <a:off x="0" y="0"/>
+            <a:ext cx="12191695" cy="1005840"/>
+          </a:xfrm>
+          <a:prstGeom prst="rect">
+            <a:avLst/>
+          </a:prstGeom>
+          <a:solidFill>
+            <a:srgbClr val="122A4A"/>
+          </a:solidFill>
+          <a:ln>
+            <a:noFill/>
+          </a:ln>
+        </p:spPr>
+        <p:style>
+          <a:lnRef idx="1">
+            <a:schemeClr val="accent1"/>
+          </a:lnRef>
+          <a:fillRef idx="3">
+            <a:schemeClr val="accent1"/>
+          </a:fillRef>
+          <a:effectRef idx="2">
+            <a:schemeClr val="accent1"/>
+          </a:effectRef>
+          <a:fontRef idx="minor">
+            <a:schemeClr val="lt1"/>
+          </a:fontRef>
+        </p:style>
+        <p:txBody>
+          <a:bodyPr rtlCol="0" anchor="ctr"/>
+          <a:lstStyle/>
+          <a:p>
+            <a:pPr algn="ctr"/>
+          </a:p>
+        </p:txBody>
+      </p:sp>
+      <p:sp>
+        <p:nvSpPr>
+          <p:cNvPr id="3" name="TextBox 2"/>
+          <p:cNvSpPr txBox="1"/>
+          <p:nvPr/>
+        </p:nvSpPr>
+        <p:spPr>
+          <a:xfrm>
+            <a:off x="548640" y="201168"/>
+            <a:ext cx="11064240" cy="731520"/>
+          </a:xfrm>
+          <a:prstGeom prst="rect">
+            <a:avLst/>
+          </a:prstGeom>
+          <a:noFill/>
+        </p:spPr>
+        <p:txBody>
+          <a:bodyPr wrap="square">
+            <a:spAutoFit/>
+          </a:bodyPr>
+          <a:lstStyle/>
+          <a:p>
+            <a:pPr>
+              <a:defRPr sz="2600" b="1">
+                <a:solidFill>
+                  <a:srgbClr val="FFFFFF"/>
+                </a:solidFill>
+                <a:latin typeface="Microsoft YaHei"/>
+              </a:defRPr>
+            </a:pPr>
+            <a:r>
+              <a:t>13 · 结论</a:t>
             </a:r>
           </a:p>
         </p:txBody>

</xml_diff>